<commit_message>
docs: add Windows download and real Plot Docs screenshots
Refresh bundled templates without legacy branding, add the Windows EXE download link, and include screenshots of every editor plus the local account flow.
</commit_message>
<xml_diff>
--- a/apps/shell/resources/templates/Product Launch.pptx
+++ b/apps/shell/resources/templates/Product Launch.pptx
@@ -3288,7 +3288,7 @@
                 </a:solidFill>
                 <a:latin typeface="Calibri"/>
               </a:rPr>
-              <a:t>A coordinated launch plan for the next chapter of Plot Docs Suite.</a:t>
+              <a:t>A coordinated launch plan for the next chapter of Plot Docs.</a:t>
             </a:r>
           </a:p>
         </p:txBody>
@@ -3323,7 +3323,7 @@
                 </a:solidFill>
                 <a:latin typeface="Calibri"/>
               </a:rPr>
-              <a:t>PLOT DOCS SUITE  /  TEMPLATE LIBRARY</a:t>
+              <a:t>PLOT DOCS  /  TEMPLATE LIBRARY</a:t>
             </a:r>
           </a:p>
         </p:txBody>
@@ -3463,7 +3463,7 @@
                 </a:solidFill>
                 <a:latin typeface="Calibri"/>
               </a:rPr>
-              <a:t>PLOT DOCS SUITE</a:t>
+              <a:t>PLOT DOCS</a:t>
             </a:r>
           </a:p>
         </p:txBody>
@@ -4062,7 +4062,7 @@
                 </a:solidFill>
                 <a:latin typeface="Calibri"/>
               </a:rPr>
-              <a:t>PLOT DOCS SUITE</a:t>
+              <a:t>PLOT DOCS</a:t>
             </a:r>
           </a:p>
         </p:txBody>
@@ -4513,7 +4513,7 @@
                 </a:solidFill>
                 <a:latin typeface="Calibri"/>
               </a:rPr>
-              <a:t>PLOT DOCS SUITE</a:t>
+              <a:t>PLOT DOCS</a:t>
             </a:r>
           </a:p>
         </p:txBody>
@@ -5349,7 +5349,7 @@
                 </a:solidFill>
                 <a:latin typeface="Calibri"/>
               </a:rPr>
-              <a:t>PLOT DOCS SUITE</a:t>
+              <a:t>PLOT DOCS</a:t>
             </a:r>
           </a:p>
         </p:txBody>

</xml_diff>